<commit_message>
Rename krb-credd to orthrus
Renames the broker daemon from krb-credd to orthrus across code, packaging,
systemd, scripts, docs and diagrams:

- console script, bin/ wrapper and systemd unit are now orthrus
- docs/krb-credd-* and docs/craft-vs-krb-credd-* files renamed to orthrus
- matplotlib diagrams regenerated from their scripts; data-flow-executive
  PNG/PDF re-rendered from the updated SVG
- Office documents updated in place

Kept unchanged so existing deployments keep working: Python module
krbhpc.credd, /etc/krb-hpc/credd.conf, and the /etc, /var/lib and /run
krb-hpc paths. CHANGELOG history and recorded test output keep the old name.

Co-Authored-By: Claude Opus 5.5 <noreply@anthropic.com>
Claude-Session: https://claude.ai/code/session_01YXWe6Bttfs9f2iyVP3TzzG
</commit_message>
<xml_diff>
--- a/docs/shared-home-kerberos-slides.pptx
+++ b/docs/shared-home-kerberos-slides.pptx
@@ -3746,7 +3746,7 @@
                   <a:schemeClr val="bg2"/>
                 </a:solidFill>
               </a:rPr>
-              <a:t>How krb-credd gives every Slurm job Active Directory Kerberos tickets — with one broker key, constrained delegation and the shared home directory</a:t>
+              <a:t>How orthrus gives every Slurm job Active Directory Kerberos tickets — with one broker key, constrained delegation and the shared home directory</a:t>
             </a:r>
             <a:endParaRPr lang="en-US" sz="1800" dirty="0"/>
           </a:p>
@@ -9626,7 +9626,7 @@
                   <a:schemeClr val="tx2"/>
                 </a:solidFill>
               </a:rPr>
-              <a:t>Supporting it: krb-credd --check</a:t>
+              <a:t>Supporting it: orthrus --check</a:t>
             </a:r>
             <a:endParaRPr lang="en-US" sz="2600" dirty="0"/>
           </a:p>
@@ -9692,7 +9692,7 @@
                 <a:ea typeface="Courier New" pitchFamily="34" charset="-122"/>
                 <a:cs typeface="Courier New" pitchFamily="34" charset="-120"/>
               </a:rPr>
-              <a:t># krb-credd --check --user jdoe</a:t>
+              <a:t># orthrus --check --user jdoe</a:t>
             </a:r>
             <a:endParaRPr lang="en-US" sz="1100" dirty="0"/>
           </a:p>
@@ -16432,7 +16432,7 @@
       </p:sp>
       <p:pic>
         <p:nvPicPr>
-          <p:cNvPr id="3" name="system architecture diagram" descr="krb-credd system architecture with numbered flow">    </p:cNvPr>
+          <p:cNvPr id="3" name="system architecture diagram" descr="orthrus system architecture with numbered flow">    </p:cNvPr>
           <p:cNvPicPr>
             <a:picLocks noChangeAspect="1"/>
           </p:cNvPicPr>
@@ -17161,7 +17161,7 @@
                   <a:schemeClr val="tx1"/>
                 </a:solidFill>
               </a:rPr>
-              <a:t>Labelled failures, krb-credd --check, config typos reported</a:t>
+              <a:t>Labelled failures, orthrus --check, config typos reported</a:t>
             </a:r>
             <a:endParaRPr lang="en-US" sz="1200" dirty="0"/>
           </a:p>

</xml_diff>